<commit_message>
Use bite-wise.org: support@bite-wise.org and www.bite-wise.org
Receipts, the sign-up confirmation email, the default support and from addresses, and the
restaurant sales pitch deck now use the new domain.

Co-Authored-By: Claude Opus 5.5 <noreply@anthropic.com>
Claude-Session: https://claude.ai/code/session_01TTXERQ5iqw3mLUpLGAhJam
</commit_message>
<xml_diff>
--- a/docs/business/Bite-Wise-Restaurant-Sales-Pitch.pptx
+++ b/docs/business/Bite-Wise-Restaurant-Sales-Pitch.pptx
@@ -116,36 +116,36 @@
   <p:extLst>
     <p:ext uri="{521415D9-36F7-43E2-AB2F-B90AF26B5E84}">
       <p14:sectionLst xmlns:p14="http://schemas.microsoft.com/office/powerpoint/2010/main">
-        <p14:section name="Opening" id="{c91e5e20-9766-1fd4-ae23-1a4aa994ad97}">
+        <p14:section name="Opening" id="{f2a00b38-042a-951b-2949-c1402c855fb3}">
           <p14:sldIdLst>
             <p14:sldId id="256"/>
           </p14:sldIdLst>
         </p14:section>
-        <p14:section name="Why Bite Wise" id="{7010bb6b-7019-4af2-219a-55e1a1f4efbd}">
+        <p14:section name="Why Bite Wise" id="{3ff2029e-52dd-1e93-f633-d3e1b201cadf}">
           <p14:sldIdLst>
             <p14:sldId id="257"/>
             <p14:sldId id="258"/>
           </p14:sldIdLst>
         </p14:section>
-        <p14:section name="The product" id="{7b785db1-207a-d122-3073-34fb04fcaf29}">
+        <p14:section name="The product" id="{c36b2471-12e8-c766-1043-b08eb2ebd87e}">
           <p14:sldIdLst>
             <p14:sldId id="259"/>
             <p14:sldId id="260"/>
             <p14:sldId id="261"/>
           </p14:sldIdLst>
         </p14:section>
-        <p14:section name="Pricing" id="{e71fa32d-360e-5a2f-55e2-03a55d3af164}">
+        <p14:section name="Pricing" id="{73460876-97b1-45a4-746f-93cf7332ebfa}">
           <p14:sldIdLst>
             <p14:sldId id="262"/>
             <p14:sldId id="263"/>
           </p14:sldIdLst>
         </p14:section>
-        <p14:section name="Trust" id="{d66cb8ce-c444-494c-d11e-a561a1a3b51b}">
+        <p14:section name="Trust" id="{acf22d6f-c63e-9191-36c0-97f1176e8a27}">
           <p14:sldIdLst>
             <p14:sldId id="264"/>
           </p14:sldIdLst>
         </p14:section>
-        <p14:section name="Next steps" id="{c417bb9a-de1d-5dc6-0e79-38bafefa8138}">
+        <p14:section name="Next steps" id="{e20b1e27-2cdb-9cd3-18c3-1620e302688f}">
           <p14:sldIdLst>
             <p14:sldId id="265"/>
           </p14:sldIdLst>
@@ -3183,8 +3183,8 @@
         </p:nvSpPr>
         <p:spPr>
           <a:xfrm>
-            <a:off x="7315200" y="4937760"/>
-            <a:ext cx="4023360" cy="457200"/>
+            <a:off x="7315200" y="4754880"/>
+            <a:ext cx="4023360" cy="777240"/>
           </a:xfrm>
           <a:prstGeom prst="rect">
             <a:avLst/>
@@ -3200,12 +3200,40 @@
               <a:buNone/>
             </a:pPr>
             <a:r>
-              <a:rPr lang="en-US" sz="1800" b="1" dirty="0">
+              <a:rPr lang="en-US" sz="1800" b="1" u="sng" dirty="0">
                 <a:solidFill>
                   <a:schemeClr val="accent1"/>
                 </a:solidFill>
-              </a:rPr>
-              <a:t>bitewise.app  ·  support@bitewise.app</a:t>
+                <a:hlinkClick r:id="rId3" invalidUrl="" action="" tgtFrame="" tooltip="" history="1" highlightClick="0" endSnd="0">
+                  <a:extLst>
+                    <a:ext uri="{A12FA001-AC4F-418D-AE19-62706E023703}">
+                      <ahyp:hlinkClr xmlns:ahyp="http://schemas.microsoft.com/office/drawing/2018/hyperlinkcolor" val="tx"/>
+                    </a:ext>
+                  </a:extLst>
+                </a:hlinkClick>
+              </a:rPr>
+              <a:t>www.bite-wise.org</a:t>
+            </a:r>
+            <a:endParaRPr lang="en-US" sz="1800" dirty="0"/>
+          </a:p>
+          <a:p>
+            <a:pPr indent="0" marL="0">
+              <a:buNone/>
+            </a:pPr>
+            <a:r>
+              <a:rPr lang="en-US" sz="1800" b="1" u="sng" dirty="0">
+                <a:solidFill>
+                  <a:schemeClr val="accent1"/>
+                </a:solidFill>
+                <a:hlinkClick r:id="rId4" invalidUrl="" action="" tgtFrame="" tooltip="" history="1" highlightClick="0" endSnd="0">
+                  <a:extLst>
+                    <a:ext uri="{A12FA001-AC4F-418D-AE19-62706E023703}">
+                      <ahyp:hlinkClr xmlns:ahyp="http://schemas.microsoft.com/office/drawing/2018/hyperlinkcolor" val="tx"/>
+                    </a:ext>
+                  </a:extLst>
+                </a:hlinkClick>
+              </a:rPr>
+              <a:t>support@bite-wise.org</a:t>
             </a:r>
             <a:endParaRPr lang="en-US" sz="1800" dirty="0"/>
           </a:p>

</xml_diff>